<commit_message>
Update prestressed variant to box-girder caisson model
Align variante B with the thesis reference (trapezoidal prestressed
concrete box girder, oval piers) and refresh PPTX/PDF plates.

Co-authored-by: Mamady10 <Mamady10@users.noreply.github.com>
</commit_message>
<xml_diff>
--- a/exports/Conceptions_Architecturales_Variantes_Pont.pptx
+++ b/exports/Conceptions_Architecturales_Variantes_Pont.pptx
@@ -16,8 +16,6 @@
     <p:sldId id="264" r:id="rId15"/>
     <p:sldId id="265" r:id="rId16"/>
     <p:sldId id="266" r:id="rId17"/>
-    <p:sldId id="267" r:id="rId18"/>
-    <p:sldId id="268" r:id="rId19"/>
   </p:sldIdLst>
   <p:sldSz cx="12191695" cy="6858000" type="screen4x3"/>
   <p:notesSz cx="6858000" cy="9144000"/>
@@ -3109,13 +3107,13 @@
         <p:spPr>
           <a:xfrm>
             <a:off x="0" y="0"/>
-            <a:ext cx="12191695" cy="6858000"/>
+            <a:ext cx="12191695" cy="640080"/>
           </a:xfrm>
           <a:prstGeom prst="rect">
             <a:avLst/>
           </a:prstGeom>
           <a:solidFill>
-            <a:srgbClr val="F7F5F1"/>
+            <a:srgbClr val="0A2540"/>
           </a:solidFill>
           <a:ln>
             <a:noFill/>
@@ -3145,57 +3143,14 @@
       </p:sp>
       <p:sp>
         <p:nvSpPr>
-          <p:cNvPr id="3" name="Rectangle 2"/>
-          <p:cNvSpPr/>
-          <p:nvPr/>
-        </p:nvSpPr>
-        <p:spPr>
-          <a:xfrm>
-            <a:off x="0" y="0"/>
-            <a:ext cx="12191695" cy="685800"/>
-          </a:xfrm>
-          <a:prstGeom prst="rect">
-            <a:avLst/>
-          </a:prstGeom>
-          <a:solidFill>
-            <a:srgbClr val="0A2540"/>
-          </a:solidFill>
-          <a:ln>
-            <a:noFill/>
-          </a:ln>
-        </p:spPr>
-        <p:style>
-          <a:lnRef idx="1">
-            <a:schemeClr val="accent1"/>
-          </a:lnRef>
-          <a:fillRef idx="3">
-            <a:schemeClr val="accent1"/>
-          </a:fillRef>
-          <a:effectRef idx="2">
-            <a:schemeClr val="accent1"/>
-          </a:effectRef>
-          <a:fontRef idx="minor">
-            <a:schemeClr val="lt1"/>
-          </a:fontRef>
-        </p:style>
-        <p:txBody>
-          <a:bodyPr rtlCol="0" anchor="ctr"/>
-          <a:lstStyle/>
-          <a:p>
-            <a:pPr algn="ctr"/>
-          </a:p>
-        </p:txBody>
-      </p:sp>
-      <p:sp>
-        <p:nvSpPr>
-          <p:cNvPr id="4" name="TextBox 3"/>
+          <p:cNvPr id="3" name="TextBox 2"/>
           <p:cNvSpPr txBox="1"/>
           <p:nvPr/>
         </p:nvSpPr>
         <p:spPr>
           <a:xfrm>
-            <a:off x="365760" y="137160"/>
-            <a:ext cx="11430000" cy="457200"/>
+            <a:off x="320040" y="109728"/>
+            <a:ext cx="11521440" cy="411480"/>
           </a:xfrm>
           <a:prstGeom prst="rect">
             <a:avLst/>
@@ -3209,152 +3164,42 @@
           <a:lstStyle/>
           <a:p>
             <a:pPr>
-              <a:defRPr sz="2000" b="1">
+              <a:defRPr sz="1700" b="1">
                 <a:solidFill>
                   <a:srgbClr val="FFFFFF"/>
                 </a:solidFill>
               </a:defRPr>
             </a:pPr>
             <a:r>
-              <a:t>CONCEPTIONS ARCHITECTURALES — VARIANTES DE PONT</a:t>
-            </a:r>
-          </a:p>
-        </p:txBody>
-      </p:sp>
-      <p:sp>
-        <p:nvSpPr>
-          <p:cNvPr id="5" name="TextBox 4"/>
-          <p:cNvSpPr txBox="1"/>
+              <a:t>1/11 VARIANTE A — Profil longitudinal (tablier mixte)</a:t>
+            </a:r>
+          </a:p>
+        </p:txBody>
+      </p:sp>
+      <p:pic>
+        <p:nvPicPr>
+          <p:cNvPr id="4" name="Picture 3" descr="01_mixte_profil_longitudinal.png"/>
+          <p:cNvPicPr>
+            <a:picLocks noChangeAspect="1"/>
+          </p:cNvPicPr>
           <p:nvPr/>
-        </p:nvSpPr>
-        <p:spPr>
-          <a:xfrm>
-            <a:off x="731520" y="1280160"/>
-            <a:ext cx="10789920" cy="4572000"/>
+        </p:nvPicPr>
+        <p:blipFill>
+          <a:blip r:embed="rId2"/>
+          <a:stretch>
+            <a:fillRect/>
+          </a:stretch>
+        </p:blipFill>
+        <p:spPr>
+          <a:xfrm>
+            <a:off x="320040" y="822960"/>
+            <a:ext cx="11521440" cy="3008028"/>
           </a:xfrm>
           <a:prstGeom prst="rect">
             <a:avLst/>
           </a:prstGeom>
-          <a:noFill/>
-        </p:spPr>
-        <p:txBody>
-          <a:bodyPr wrap="none">
-            <a:spAutoFit/>
-          </a:bodyPr>
-          <a:lstStyle/>
-          <a:p>
-            <a:pPr>
-              <a:defRPr sz="2800" b="1">
-                <a:solidFill>
-                  <a:srgbClr val="0A2540"/>
-                </a:solidFill>
-              </a:defRPr>
-            </a:pPr>
-            <a:r>
-              <a:t>Portée étudiée : 4 × 15,70 m = 62,80 m</a:t>
-            </a:r>
-          </a:p>
-          <a:p>
-            <a:pPr>
-              <a:defRPr sz="1400" b="0">
-                <a:solidFill>
-                  <a:srgbClr val="5A5A5A"/>
-                </a:solidFill>
-              </a:defRPr>
-            </a:pPr>
-          </a:p>
-          <a:p>
-            <a:pPr>
-              <a:defRPr sz="2000" b="1">
-                <a:solidFill>
-                  <a:srgbClr val="0A2540"/>
-                </a:solidFill>
-              </a:defRPr>
-            </a:pPr>
-            <a:r>
-              <a:t>Variante A — Pont à tablier mixte (béton armé + poutres acier)</a:t>
-            </a:r>
-          </a:p>
-          <a:p>
-            <a:pPr>
-              <a:defRPr sz="2000" b="1">
-                <a:solidFill>
-                  <a:srgbClr val="2F6B4F"/>
-                </a:solidFill>
-              </a:defRPr>
-            </a:pPr>
-            <a:r>
-              <a:t>Variante B — Pont en béton précontraint (poutres préfabriquées)</a:t>
-            </a:r>
-          </a:p>
-          <a:p>
-            <a:pPr>
-              <a:defRPr sz="1400" b="0">
-                <a:solidFill>
-                  <a:srgbClr val="5A5A5A"/>
-                </a:solidFill>
-              </a:defRPr>
-            </a:pPr>
-          </a:p>
-          <a:p>
-            <a:pPr>
-              <a:defRPr sz="1600" b="0">
-                <a:solidFill>
-                  <a:srgbClr val="5A5A5A"/>
-                </a:solidFill>
-              </a:defRPr>
-            </a:pPr>
-            <a:r>
-              <a:t>Vues : profil longitudinal • vue en plan • coupe transversale • détail technique</a:t>
-            </a:r>
-          </a:p>
-          <a:p>
-            <a:pPr>
-              <a:defRPr sz="1400" b="0">
-                <a:solidFill>
-                  <a:srgbClr val="5A5A5A"/>
-                </a:solidFill>
-              </a:defRPr>
-            </a:pPr>
-          </a:p>
-          <a:p>
-            <a:pPr>
-              <a:defRPr sz="1600" b="0">
-                <a:solidFill>
-                  <a:srgbClr val="5A5A5A"/>
-                </a:solidFill>
-              </a:defRPr>
-            </a:pPr>
-            <a:r>
-              <a:t>Réalisé par : Mamady KABA &amp; Thierno Ibrahima Hassanatou Diallo</a:t>
-            </a:r>
-          </a:p>
-          <a:p>
-            <a:pPr>
-              <a:defRPr sz="1600" b="0">
-                <a:solidFill>
-                  <a:srgbClr val="5A5A5A"/>
-                </a:solidFill>
-              </a:defRPr>
-            </a:pPr>
-            <a:r>
-              <a:t>Encadré par : Monsieur Fodé Bangaly Keita</a:t>
-            </a:r>
-          </a:p>
-          <a:p>
-            <a:pPr>
-              <a:defRPr sz="1600" b="0">
-                <a:solidFill>
-                  <a:srgbClr val="5A5A5A"/>
-                </a:solidFill>
-              </a:defRPr>
-            </a:pPr>
-            <a:r>
-              <a:t>Mémoire d'ingénieurs — Ponts et chaussées</a:t>
-            </a:r>
-          </a:p>
-        </p:txBody>
-      </p:sp>
+        </p:spPr>
+      </p:pic>
     </p:spTree>
   </p:cSld>
   <p:clrMapOvr>
@@ -3382,13 +3227,13 @@
         <p:spPr>
           <a:xfrm>
             <a:off x="0" y="0"/>
-            <a:ext cx="12191695" cy="685800"/>
+            <a:ext cx="12191695" cy="640080"/>
           </a:xfrm>
           <a:prstGeom prst="rect">
             <a:avLst/>
           </a:prstGeom>
           <a:solidFill>
-            <a:srgbClr val="C45C26"/>
+            <a:srgbClr val="0A2540"/>
           </a:solidFill>
           <a:ln>
             <a:noFill/>
@@ -3424,8 +3269,8 @@
         </p:nvSpPr>
         <p:spPr>
           <a:xfrm>
-            <a:off x="365760" y="137160"/>
-            <a:ext cx="11430000" cy="457200"/>
+            <a:off x="320040" y="109728"/>
+            <a:ext cx="11521440" cy="411480"/>
           </a:xfrm>
           <a:prstGeom prst="rect">
             <a:avLst/>
@@ -3439,21 +3284,21 @@
           <a:lstStyle/>
           <a:p>
             <a:pPr>
-              <a:defRPr sz="2000" b="1">
+              <a:defRPr sz="1700" b="1">
                 <a:solidFill>
                   <a:srgbClr val="FFFFFF"/>
                 </a:solidFill>
               </a:defRPr>
             </a:pPr>
             <a:r>
-              <a:t>COMPARAISON DES DEUX VARIANTES ARCHITECTURALES</a:t>
+              <a:t>10/11 VARIANTE A — Perspective architecturale</a:t>
             </a:r>
           </a:p>
         </p:txBody>
       </p:sp>
       <p:pic>
         <p:nvPicPr>
-          <p:cNvPr id="4" name="Picture 3" descr="09_comparatif_variantes.png"/>
+          <p:cNvPr id="4" name="Picture 3" descr="10_mixte_perspective_architecturale.png"/>
           <p:cNvPicPr>
             <a:picLocks noChangeAspect="1"/>
           </p:cNvPicPr>
@@ -3467,8 +3312,8 @@
         </p:blipFill>
         <p:spPr>
           <a:xfrm>
-            <a:off x="320040" y="868680"/>
-            <a:ext cx="11521440" cy="4510395"/>
+            <a:off x="320040" y="822960"/>
+            <a:ext cx="11521440" cy="7680960"/>
           </a:xfrm>
           <a:prstGeom prst="rect">
             <a:avLst/>
@@ -3502,13 +3347,13 @@
         <p:spPr>
           <a:xfrm>
             <a:off x="0" y="0"/>
-            <a:ext cx="12191695" cy="685800"/>
+            <a:ext cx="12191695" cy="640080"/>
           </a:xfrm>
           <a:prstGeom prst="rect">
             <a:avLst/>
           </a:prstGeom>
           <a:solidFill>
-            <a:srgbClr val="0A2540"/>
+            <a:srgbClr val="2F6B4F"/>
           </a:solidFill>
           <a:ln>
             <a:noFill/>
@@ -3544,8 +3389,8 @@
         </p:nvSpPr>
         <p:spPr>
           <a:xfrm>
-            <a:off x="365760" y="137160"/>
-            <a:ext cx="11430000" cy="457200"/>
+            <a:off x="320040" y="109728"/>
+            <a:ext cx="11521440" cy="411480"/>
           </a:xfrm>
           <a:prstGeom prst="rect">
             <a:avLst/>
@@ -3559,343 +3404,14 @@
           <a:lstStyle/>
           <a:p>
             <a:pPr>
-              <a:defRPr sz="2000" b="1">
+              <a:defRPr sz="1700" b="1">
                 <a:solidFill>
                   <a:srgbClr val="FFFFFF"/>
                 </a:solidFill>
               </a:defRPr>
             </a:pPr>
             <a:r>
-              <a:t>SYNTHÈSE CONCEPTUELLE POUR LE MÉMOIRE</a:t>
-            </a:r>
-          </a:p>
-        </p:txBody>
-      </p:sp>
-      <p:sp>
-        <p:nvSpPr>
-          <p:cNvPr id="4" name="TextBox 3"/>
-          <p:cNvSpPr txBox="1"/>
-          <p:nvPr/>
-        </p:nvSpPr>
-        <p:spPr>
-          <a:xfrm>
-            <a:off x="640080" y="1097280"/>
-            <a:ext cx="10972800" cy="5029200"/>
-          </a:xfrm>
-          <a:prstGeom prst="rect">
-            <a:avLst/>
-          </a:prstGeom>
-          <a:noFill/>
-        </p:spPr>
-        <p:txBody>
-          <a:bodyPr wrap="none">
-            <a:spAutoFit/>
-          </a:bodyPr>
-          <a:lstStyle/>
-          <a:p>
-            <a:pPr>
-              <a:spcAft>
-                <a:spcPts val="1000"/>
-              </a:spcAft>
-              <a:defRPr sz="1700">
-                <a:solidFill>
-                  <a:srgbClr val="1E1E1E"/>
-                </a:solidFill>
-              </a:defRPr>
-            </a:pPr>
-            <a:r>
-              <a:t>•  Les deux variantes respectent la même géométrie : 4 travées de 15,70 m (L = 62,80 m), largeur utile 8,00 m.</a:t>
-            </a:r>
-          </a:p>
-          <a:p>
-            <a:pPr>
-              <a:spcAft>
-                <a:spcPts val="1000"/>
-              </a:spcAft>
-              <a:defRPr sz="1700">
-                <a:solidFill>
-                  <a:srgbClr val="1E1E1E"/>
-                </a:solidFill>
-              </a:defRPr>
-            </a:pPr>
-            <a:r>
-              <a:t>•  Variante A (mixte) : dalle BA collaborante sur poutres acier — tablier léger, montage rapide, hauteur constructive réduite.</a:t>
-            </a:r>
-          </a:p>
-          <a:p>
-            <a:pPr>
-              <a:spcAft>
-                <a:spcPts val="1000"/>
-              </a:spcAft>
-              <a:defRPr sz="1700">
-                <a:solidFill>
-                  <a:srgbClr val="1E1E1E"/>
-                </a:solidFill>
-              </a:defRPr>
-            </a:pPr>
-            <a:r>
-              <a:t>•  Variante B (précontraint) : poutres I préfabriquées + hourdis — qualité usine, durabilité, câbles en parabole.</a:t>
-            </a:r>
-          </a:p>
-          <a:p>
-            <a:pPr>
-              <a:spcAft>
-                <a:spcPts val="1000"/>
-              </a:spcAft>
-              <a:defRPr sz="1700">
-                <a:solidFill>
-                  <a:srgbClr val="1E1E1E"/>
-                </a:solidFill>
-              </a:defRPr>
-            </a:pPr>
-            <a:r>
-              <a:t>•  Appuis communs : culées H = 5 m, 3 piles, chevêtres, appareils d'appui élastomères, semelles.</a:t>
-            </a:r>
-          </a:p>
-          <a:p>
-            <a:pPr>
-              <a:spcAft>
-                <a:spcPts val="1000"/>
-              </a:spcAft>
-              <a:defRPr sz="1700">
-                <a:solidFill>
-                  <a:srgbClr val="1E1E1E"/>
-                </a:solidFill>
-              </a:defRPr>
-            </a:pPr>
-            <a:r>
-              <a:t>•  Hydraulique commune : NPBE = 1,00 m • NPHE = 4,00 m • Affouillement prévu = 5,00 m.</a:t>
-            </a:r>
-          </a:p>
-          <a:p>
-            <a:pPr>
-              <a:spcAft>
-                <a:spcPts val="1000"/>
-              </a:spcAft>
-              <a:defRPr sz="1700">
-                <a:solidFill>
-                  <a:srgbClr val="1E1E1E"/>
-                </a:solidFill>
-              </a:defRPr>
-            </a:pPr>
-            <a:r>
-              <a:t>•  La variante BA (déjà retenue dans le mémoire) reste la référence ; A et B servent à la comparaison multicritère.</a:t>
-            </a:r>
-          </a:p>
-        </p:txBody>
-      </p:sp>
-    </p:spTree>
-  </p:cSld>
-  <p:clrMapOvr>
-    <a:masterClrMapping/>
-  </p:clrMapOvr>
-</p:sld>
-</file>
-
-<file path=ppt/slides/slide12.xml><?xml version="1.0" encoding="utf-8"?>
-<p:sld xmlns:a="http://schemas.openxmlformats.org/drawingml/2006/main" xmlns:p="http://schemas.openxmlformats.org/presentationml/2006/main" xmlns:r="http://schemas.openxmlformats.org/officeDocument/2006/relationships">
-  <p:cSld>
-    <p:spTree>
-      <p:nvGrpSpPr>
-        <p:cNvPr id="1" name=""/>
-        <p:cNvGrpSpPr/>
-        <p:nvPr/>
-      </p:nvGrpSpPr>
-      <p:grpSpPr/>
-      <p:sp>
-        <p:nvSpPr>
-          <p:cNvPr id="2" name="Rectangle 1"/>
-          <p:cNvSpPr/>
-          <p:nvPr/>
-        </p:nvSpPr>
-        <p:spPr>
-          <a:xfrm>
-            <a:off x="0" y="0"/>
-            <a:ext cx="12191695" cy="685800"/>
-          </a:xfrm>
-          <a:prstGeom prst="rect">
-            <a:avLst/>
-          </a:prstGeom>
-          <a:solidFill>
-            <a:srgbClr val="0A2540"/>
-          </a:solidFill>
-          <a:ln>
-            <a:noFill/>
-          </a:ln>
-        </p:spPr>
-        <p:style>
-          <a:lnRef idx="1">
-            <a:schemeClr val="accent1"/>
-          </a:lnRef>
-          <a:fillRef idx="3">
-            <a:schemeClr val="accent1"/>
-          </a:fillRef>
-          <a:effectRef idx="2">
-            <a:schemeClr val="accent1"/>
-          </a:effectRef>
-          <a:fontRef idx="minor">
-            <a:schemeClr val="lt1"/>
-          </a:fontRef>
-        </p:style>
-        <p:txBody>
-          <a:bodyPr rtlCol="0" anchor="ctr"/>
-          <a:lstStyle/>
-          <a:p>
-            <a:pPr algn="ctr"/>
-          </a:p>
-        </p:txBody>
-      </p:sp>
-      <p:sp>
-        <p:nvSpPr>
-          <p:cNvPr id="3" name="TextBox 2"/>
-          <p:cNvSpPr txBox="1"/>
-          <p:nvPr/>
-        </p:nvSpPr>
-        <p:spPr>
-          <a:xfrm>
-            <a:off x="365760" y="137160"/>
-            <a:ext cx="11430000" cy="457200"/>
-          </a:xfrm>
-          <a:prstGeom prst="rect">
-            <a:avLst/>
-          </a:prstGeom>
-          <a:noFill/>
-        </p:spPr>
-        <p:txBody>
-          <a:bodyPr wrap="none">
-            <a:spAutoFit/>
-          </a:bodyPr>
-          <a:lstStyle/>
-          <a:p>
-            <a:pPr>
-              <a:defRPr sz="2000" b="1">
-                <a:solidFill>
-                  <a:srgbClr val="FFFFFF"/>
-                </a:solidFill>
-              </a:defRPr>
-            </a:pPr>
-            <a:r>
-              <a:t>VARIANTE A — Perspective architecturale (tablier mixte)</a:t>
-            </a:r>
-          </a:p>
-        </p:txBody>
-      </p:sp>
-      <p:pic>
-        <p:nvPicPr>
-          <p:cNvPr id="4" name="Picture 3" descr="10_mixte_perspective_architecturale.png"/>
-          <p:cNvPicPr>
-            <a:picLocks noChangeAspect="1"/>
-          </p:cNvPicPr>
-          <p:nvPr/>
-        </p:nvPicPr>
-        <p:blipFill>
-          <a:blip r:embed="rId2"/>
-          <a:stretch>
-            <a:fillRect/>
-          </a:stretch>
-        </p:blipFill>
-        <p:spPr>
-          <a:xfrm>
-            <a:off x="548640" y="914400"/>
-            <a:ext cx="11064240" cy="7376160"/>
-          </a:xfrm>
-          <a:prstGeom prst="rect">
-            <a:avLst/>
-          </a:prstGeom>
-        </p:spPr>
-      </p:pic>
-    </p:spTree>
-  </p:cSld>
-  <p:clrMapOvr>
-    <a:masterClrMapping/>
-  </p:clrMapOvr>
-</p:sld>
-</file>
-
-<file path=ppt/slides/slide13.xml><?xml version="1.0" encoding="utf-8"?>
-<p:sld xmlns:a="http://schemas.openxmlformats.org/drawingml/2006/main" xmlns:p="http://schemas.openxmlformats.org/presentationml/2006/main" xmlns:r="http://schemas.openxmlformats.org/officeDocument/2006/relationships">
-  <p:cSld>
-    <p:spTree>
-      <p:nvGrpSpPr>
-        <p:cNvPr id="1" name=""/>
-        <p:cNvGrpSpPr/>
-        <p:nvPr/>
-      </p:nvGrpSpPr>
-      <p:grpSpPr/>
-      <p:sp>
-        <p:nvSpPr>
-          <p:cNvPr id="2" name="Rectangle 1"/>
-          <p:cNvSpPr/>
-          <p:nvPr/>
-        </p:nvSpPr>
-        <p:spPr>
-          <a:xfrm>
-            <a:off x="0" y="0"/>
-            <a:ext cx="12191695" cy="685800"/>
-          </a:xfrm>
-          <a:prstGeom prst="rect">
-            <a:avLst/>
-          </a:prstGeom>
-          <a:solidFill>
-            <a:srgbClr val="2F6B4F"/>
-          </a:solidFill>
-          <a:ln>
-            <a:noFill/>
-          </a:ln>
-        </p:spPr>
-        <p:style>
-          <a:lnRef idx="1">
-            <a:schemeClr val="accent1"/>
-          </a:lnRef>
-          <a:fillRef idx="3">
-            <a:schemeClr val="accent1"/>
-          </a:fillRef>
-          <a:effectRef idx="2">
-            <a:schemeClr val="accent1"/>
-          </a:effectRef>
-          <a:fontRef idx="minor">
-            <a:schemeClr val="lt1"/>
-          </a:fontRef>
-        </p:style>
-        <p:txBody>
-          <a:bodyPr rtlCol="0" anchor="ctr"/>
-          <a:lstStyle/>
-          <a:p>
-            <a:pPr algn="ctr"/>
-          </a:p>
-        </p:txBody>
-      </p:sp>
-      <p:sp>
-        <p:nvSpPr>
-          <p:cNvPr id="3" name="TextBox 2"/>
-          <p:cNvSpPr txBox="1"/>
-          <p:nvPr/>
-        </p:nvSpPr>
-        <p:spPr>
-          <a:xfrm>
-            <a:off x="365760" y="137160"/>
-            <a:ext cx="11430000" cy="457200"/>
-          </a:xfrm>
-          <a:prstGeom prst="rect">
-            <a:avLst/>
-          </a:prstGeom>
-          <a:noFill/>
-        </p:spPr>
-        <p:txBody>
-          <a:bodyPr wrap="none">
-            <a:spAutoFit/>
-          </a:bodyPr>
-          <a:lstStyle/>
-          <a:p>
-            <a:pPr>
-              <a:defRPr sz="2000" b="1">
-                <a:solidFill>
-                  <a:srgbClr val="FFFFFF"/>
-                </a:solidFill>
-              </a:defRPr>
-            </a:pPr>
-            <a:r>
-              <a:t>VARIANTE B — Perspective architecturale (béton précontraint)</a:t>
+              <a:t>11/11 VARIANTE B — Perspective caisson précontraint</a:t>
             </a:r>
           </a:p>
         </p:txBody>
@@ -3916,8 +3432,8 @@
         </p:blipFill>
         <p:spPr>
           <a:xfrm>
-            <a:off x="548640" y="914400"/>
-            <a:ext cx="11064240" cy="7376160"/>
+            <a:off x="320040" y="822960"/>
+            <a:ext cx="11521440" cy="7680960"/>
           </a:xfrm>
           <a:prstGeom prst="rect">
             <a:avLst/>
@@ -3951,7 +3467,7 @@
         <p:spPr>
           <a:xfrm>
             <a:off x="0" y="0"/>
-            <a:ext cx="12191695" cy="685800"/>
+            <a:ext cx="12191695" cy="640080"/>
           </a:xfrm>
           <a:prstGeom prst="rect">
             <a:avLst/>
@@ -3993,8 +3509,8 @@
         </p:nvSpPr>
         <p:spPr>
           <a:xfrm>
-            <a:off x="365760" y="137160"/>
-            <a:ext cx="11430000" cy="457200"/>
+            <a:off x="320040" y="109728"/>
+            <a:ext cx="11521440" cy="411480"/>
           </a:xfrm>
           <a:prstGeom prst="rect">
             <a:avLst/>
@@ -4008,21 +3524,21 @@
           <a:lstStyle/>
           <a:p>
             <a:pPr>
-              <a:defRPr sz="2000" b="1">
+              <a:defRPr sz="1700" b="1">
                 <a:solidFill>
                   <a:srgbClr val="FFFFFF"/>
                 </a:solidFill>
               </a:defRPr>
             </a:pPr>
             <a:r>
-              <a:t>VARIANTE A — Profil longitudinal (tablier mixte)</a:t>
+              <a:t>2/11 VARIANTE A — Vue en plan</a:t>
             </a:r>
           </a:p>
         </p:txBody>
       </p:sp>
       <p:pic>
         <p:nvPicPr>
-          <p:cNvPr id="4" name="Picture 3" descr="01_mixte_profil_longitudinal.png"/>
+          <p:cNvPr id="4" name="Picture 3" descr="02_mixte_vue_en_plan.png"/>
           <p:cNvPicPr>
             <a:picLocks noChangeAspect="1"/>
           </p:cNvPicPr>
@@ -4036,8 +3552,8 @@
         </p:blipFill>
         <p:spPr>
           <a:xfrm>
-            <a:off x="320040" y="868680"/>
-            <a:ext cx="11521440" cy="3008028"/>
+            <a:off x="320040" y="822960"/>
+            <a:ext cx="11521440" cy="2566543"/>
           </a:xfrm>
           <a:prstGeom prst="rect">
             <a:avLst/>
@@ -4071,7 +3587,7 @@
         <p:spPr>
           <a:xfrm>
             <a:off x="0" y="0"/>
-            <a:ext cx="12191695" cy="685800"/>
+            <a:ext cx="12191695" cy="640080"/>
           </a:xfrm>
           <a:prstGeom prst="rect">
             <a:avLst/>
@@ -4113,8 +3629,8 @@
         </p:nvSpPr>
         <p:spPr>
           <a:xfrm>
-            <a:off x="365760" y="137160"/>
-            <a:ext cx="11430000" cy="457200"/>
+            <a:off x="320040" y="109728"/>
+            <a:ext cx="11521440" cy="411480"/>
           </a:xfrm>
           <a:prstGeom prst="rect">
             <a:avLst/>
@@ -4128,21 +3644,21 @@
           <a:lstStyle/>
           <a:p>
             <a:pPr>
-              <a:defRPr sz="2000" b="1">
+              <a:defRPr sz="1700" b="1">
                 <a:solidFill>
                   <a:srgbClr val="FFFFFF"/>
                 </a:solidFill>
               </a:defRPr>
             </a:pPr>
             <a:r>
-              <a:t>VARIANTE A — Vue en plan</a:t>
+              <a:t>3/11 VARIANTE A — Coupe transversale</a:t>
             </a:r>
           </a:p>
         </p:txBody>
       </p:sp>
       <p:pic>
         <p:nvPicPr>
-          <p:cNvPr id="4" name="Picture 3" descr="02_mixte_vue_en_plan.png"/>
+          <p:cNvPr id="4" name="Picture 3" descr="03_mixte_coupe_transversale.png"/>
           <p:cNvPicPr>
             <a:picLocks noChangeAspect="1"/>
           </p:cNvPicPr>
@@ -4156,8 +3672,8 @@
         </p:blipFill>
         <p:spPr>
           <a:xfrm>
-            <a:off x="320040" y="868680"/>
-            <a:ext cx="11521440" cy="2566543"/>
+            <a:off x="320040" y="822960"/>
+            <a:ext cx="11521440" cy="5234617"/>
           </a:xfrm>
           <a:prstGeom prst="rect">
             <a:avLst/>
@@ -4191,7 +3707,7 @@
         <p:spPr>
           <a:xfrm>
             <a:off x="0" y="0"/>
-            <a:ext cx="12191695" cy="685800"/>
+            <a:ext cx="12191695" cy="640080"/>
           </a:xfrm>
           <a:prstGeom prst="rect">
             <a:avLst/>
@@ -4233,8 +3749,8 @@
         </p:nvSpPr>
         <p:spPr>
           <a:xfrm>
-            <a:off x="365760" y="137160"/>
-            <a:ext cx="11430000" cy="457200"/>
+            <a:off x="320040" y="109728"/>
+            <a:ext cx="11521440" cy="411480"/>
           </a:xfrm>
           <a:prstGeom prst="rect">
             <a:avLst/>
@@ -4248,21 +3764,21 @@
           <a:lstStyle/>
           <a:p>
             <a:pPr>
-              <a:defRPr sz="2000" b="1">
+              <a:defRPr sz="1700" b="1">
                 <a:solidFill>
                   <a:srgbClr val="FFFFFF"/>
                 </a:solidFill>
               </a:defRPr>
             </a:pPr>
             <a:r>
-              <a:t>VARIANTE A — Coupe transversale</a:t>
+              <a:t>4/11 VARIANTE A — Détail connexion mixte</a:t>
             </a:r>
           </a:p>
         </p:txBody>
       </p:sp>
       <p:pic>
         <p:nvPicPr>
-          <p:cNvPr id="4" name="Picture 3" descr="03_mixte_coupe_transversale.png"/>
+          <p:cNvPr id="4" name="Picture 3" descr="04_mixte_detail_connexion.png"/>
           <p:cNvPicPr>
             <a:picLocks noChangeAspect="1"/>
           </p:cNvPicPr>
@@ -4276,8 +3792,8 @@
         </p:blipFill>
         <p:spPr>
           <a:xfrm>
-            <a:off x="320040" y="868680"/>
-            <a:ext cx="11521440" cy="5234617"/>
+            <a:off x="320040" y="822960"/>
+            <a:ext cx="11521440" cy="10562478"/>
           </a:xfrm>
           <a:prstGeom prst="rect">
             <a:avLst/>
@@ -4311,13 +3827,13 @@
         <p:spPr>
           <a:xfrm>
             <a:off x="0" y="0"/>
-            <a:ext cx="12191695" cy="685800"/>
+            <a:ext cx="12191695" cy="640080"/>
           </a:xfrm>
           <a:prstGeom prst="rect">
             <a:avLst/>
           </a:prstGeom>
           <a:solidFill>
-            <a:srgbClr val="0A2540"/>
+            <a:srgbClr val="2F6B4F"/>
           </a:solidFill>
           <a:ln>
             <a:noFill/>
@@ -4353,8 +3869,8 @@
         </p:nvSpPr>
         <p:spPr>
           <a:xfrm>
-            <a:off x="365760" y="137160"/>
-            <a:ext cx="11430000" cy="457200"/>
+            <a:off x="320040" y="109728"/>
+            <a:ext cx="11521440" cy="411480"/>
           </a:xfrm>
           <a:prstGeom prst="rect">
             <a:avLst/>
@@ -4368,21 +3884,21 @@
           <a:lstStyle/>
           <a:p>
             <a:pPr>
-              <a:defRPr sz="2000" b="1">
+              <a:defRPr sz="1700" b="1">
                 <a:solidFill>
                   <a:srgbClr val="FFFFFF"/>
                 </a:solidFill>
               </a:defRPr>
             </a:pPr>
             <a:r>
-              <a:t>VARIANTE A — Détail de connexion mixte</a:t>
+              <a:t>5/11 VARIANTE B — Profil longitudinal (caisson précontraint)</a:t>
             </a:r>
           </a:p>
         </p:txBody>
       </p:sp>
       <p:pic>
         <p:nvPicPr>
-          <p:cNvPr id="4" name="Picture 3" descr="04_mixte_detail_connexion.png"/>
+          <p:cNvPr id="4" name="Picture 3" descr="05_precontraint_profil_longitudinal.png"/>
           <p:cNvPicPr>
             <a:picLocks noChangeAspect="1"/>
           </p:cNvPicPr>
@@ -4396,8 +3912,8 @@
         </p:blipFill>
         <p:spPr>
           <a:xfrm>
-            <a:off x="320040" y="868680"/>
-            <a:ext cx="11521440" cy="10562478"/>
+            <a:off x="320040" y="822960"/>
+            <a:ext cx="11521440" cy="3103721"/>
           </a:xfrm>
           <a:prstGeom prst="rect">
             <a:avLst/>
@@ -4431,7 +3947,7 @@
         <p:spPr>
           <a:xfrm>
             <a:off x="0" y="0"/>
-            <a:ext cx="12191695" cy="685800"/>
+            <a:ext cx="12191695" cy="640080"/>
           </a:xfrm>
           <a:prstGeom prst="rect">
             <a:avLst/>
@@ -4473,8 +3989,8 @@
         </p:nvSpPr>
         <p:spPr>
           <a:xfrm>
-            <a:off x="365760" y="137160"/>
-            <a:ext cx="11430000" cy="457200"/>
+            <a:off x="320040" y="109728"/>
+            <a:ext cx="11521440" cy="411480"/>
           </a:xfrm>
           <a:prstGeom prst="rect">
             <a:avLst/>
@@ -4488,21 +4004,21 @@
           <a:lstStyle/>
           <a:p>
             <a:pPr>
-              <a:defRPr sz="2000" b="1">
+              <a:defRPr sz="1700" b="1">
                 <a:solidFill>
                   <a:srgbClr val="FFFFFF"/>
                 </a:solidFill>
               </a:defRPr>
             </a:pPr>
             <a:r>
-              <a:t>VARIANTE B — Profil longitudinal (béton précontraint)</a:t>
+              <a:t>6/11 VARIANTE B — Vue en plan (caisson)</a:t>
             </a:r>
           </a:p>
         </p:txBody>
       </p:sp>
       <p:pic>
         <p:nvPicPr>
-          <p:cNvPr id="4" name="Picture 3" descr="05_precontraint_profil_longitudinal.png"/>
+          <p:cNvPr id="4" name="Picture 3" descr="06_precontraint_vue_en_plan.png"/>
           <p:cNvPicPr>
             <a:picLocks noChangeAspect="1"/>
           </p:cNvPicPr>
@@ -4516,8 +4032,8 @@
         </p:blipFill>
         <p:spPr>
           <a:xfrm>
-            <a:off x="320040" y="868680"/>
-            <a:ext cx="11521440" cy="2994849"/>
+            <a:off x="320040" y="822960"/>
+            <a:ext cx="11521440" cy="2615963"/>
           </a:xfrm>
           <a:prstGeom prst="rect">
             <a:avLst/>
@@ -4551,7 +4067,7 @@
         <p:spPr>
           <a:xfrm>
             <a:off x="0" y="0"/>
-            <a:ext cx="12191695" cy="685800"/>
+            <a:ext cx="12191695" cy="640080"/>
           </a:xfrm>
           <a:prstGeom prst="rect">
             <a:avLst/>
@@ -4593,8 +4109,8 @@
         </p:nvSpPr>
         <p:spPr>
           <a:xfrm>
-            <a:off x="365760" y="137160"/>
-            <a:ext cx="11430000" cy="457200"/>
+            <a:off x="320040" y="109728"/>
+            <a:ext cx="11521440" cy="411480"/>
           </a:xfrm>
           <a:prstGeom prst="rect">
             <a:avLst/>
@@ -4608,21 +4124,21 @@
           <a:lstStyle/>
           <a:p>
             <a:pPr>
-              <a:defRPr sz="2000" b="1">
+              <a:defRPr sz="1700" b="1">
                 <a:solidFill>
                   <a:srgbClr val="FFFFFF"/>
                 </a:solidFill>
               </a:defRPr>
             </a:pPr>
             <a:r>
-              <a:t>VARIANTE B — Vue en plan</a:t>
+              <a:t>7/11 VARIANTE B — Coupe transversale caisson trapézoïdal</a:t>
             </a:r>
           </a:p>
         </p:txBody>
       </p:sp>
       <p:pic>
         <p:nvPicPr>
-          <p:cNvPr id="4" name="Picture 3" descr="06_precontraint_vue_en_plan.png"/>
+          <p:cNvPr id="4" name="Picture 3" descr="07_precontraint_coupe_transversale.png"/>
           <p:cNvPicPr>
             <a:picLocks noChangeAspect="1"/>
           </p:cNvPicPr>
@@ -4636,8 +4152,8 @@
         </p:blipFill>
         <p:spPr>
           <a:xfrm>
-            <a:off x="320040" y="868680"/>
-            <a:ext cx="11521440" cy="2569838"/>
+            <a:off x="320040" y="822960"/>
+            <a:ext cx="11521440" cy="5978645"/>
           </a:xfrm>
           <a:prstGeom prst="rect">
             <a:avLst/>
@@ -4671,7 +4187,7 @@
         <p:spPr>
           <a:xfrm>
             <a:off x="0" y="0"/>
-            <a:ext cx="12191695" cy="685800"/>
+            <a:ext cx="12191695" cy="640080"/>
           </a:xfrm>
           <a:prstGeom prst="rect">
             <a:avLst/>
@@ -4713,8 +4229,8 @@
         </p:nvSpPr>
         <p:spPr>
           <a:xfrm>
-            <a:off x="365760" y="137160"/>
-            <a:ext cx="11430000" cy="457200"/>
+            <a:off x="320040" y="109728"/>
+            <a:ext cx="11521440" cy="411480"/>
           </a:xfrm>
           <a:prstGeom prst="rect">
             <a:avLst/>
@@ -4728,21 +4244,21 @@
           <a:lstStyle/>
           <a:p>
             <a:pPr>
-              <a:defRPr sz="2000" b="1">
+              <a:defRPr sz="1700" b="1">
                 <a:solidFill>
                   <a:srgbClr val="FFFFFF"/>
                 </a:solidFill>
               </a:defRPr>
             </a:pPr>
             <a:r>
-              <a:t>VARIANTE B — Coupe transversale</a:t>
+              <a:t>8/11 VARIANTE B — Détail caisson / pile ovale</a:t>
             </a:r>
           </a:p>
         </p:txBody>
       </p:sp>
       <p:pic>
         <p:nvPicPr>
-          <p:cNvPr id="4" name="Picture 3" descr="07_precontraint_coupe_transversale.png"/>
+          <p:cNvPr id="4" name="Picture 3" descr="08_precontraint_detail_poutre.png"/>
           <p:cNvPicPr>
             <a:picLocks noChangeAspect="1"/>
           </p:cNvPicPr>
@@ -4756,8 +4272,8 @@
         </p:blipFill>
         <p:spPr>
           <a:xfrm>
-            <a:off x="320040" y="868680"/>
-            <a:ext cx="11521440" cy="5467951"/>
+            <a:off x="320040" y="822960"/>
+            <a:ext cx="11521440" cy="7363724"/>
           </a:xfrm>
           <a:prstGeom prst="rect">
             <a:avLst/>
@@ -4791,13 +4307,13 @@
         <p:spPr>
           <a:xfrm>
             <a:off x="0" y="0"/>
-            <a:ext cx="12191695" cy="685800"/>
+            <a:ext cx="12191695" cy="640080"/>
           </a:xfrm>
           <a:prstGeom prst="rect">
             <a:avLst/>
           </a:prstGeom>
           <a:solidFill>
-            <a:srgbClr val="2F6B4F"/>
+            <a:srgbClr val="C45C26"/>
           </a:solidFill>
           <a:ln>
             <a:noFill/>
@@ -4833,8 +4349,8 @@
         </p:nvSpPr>
         <p:spPr>
           <a:xfrm>
-            <a:off x="365760" y="137160"/>
-            <a:ext cx="11430000" cy="457200"/>
+            <a:off x="320040" y="109728"/>
+            <a:ext cx="11521440" cy="411480"/>
           </a:xfrm>
           <a:prstGeom prst="rect">
             <a:avLst/>
@@ -4848,21 +4364,21 @@
           <a:lstStyle/>
           <a:p>
             <a:pPr>
-              <a:defRPr sz="2000" b="1">
+              <a:defRPr sz="1700" b="1">
                 <a:solidFill>
                   <a:srgbClr val="FFFFFF"/>
                 </a:solidFill>
               </a:defRPr>
             </a:pPr>
             <a:r>
-              <a:t>VARIANTE B — Détail de poutre précontrainte</a:t>
+              <a:t>9/11 COMPARAISON DES DEUX VARIANTES</a:t>
             </a:r>
           </a:p>
         </p:txBody>
       </p:sp>
       <p:pic>
         <p:nvPicPr>
-          <p:cNvPr id="4" name="Picture 3" descr="08_precontraint_detail_poutre.png"/>
+          <p:cNvPr id="4" name="Picture 3" descr="09_comparatif_variantes.png"/>
           <p:cNvPicPr>
             <a:picLocks noChangeAspect="1"/>
           </p:cNvPicPr>
@@ -4876,8 +4392,8 @@
         </p:blipFill>
         <p:spPr>
           <a:xfrm>
-            <a:off x="320040" y="868680"/>
-            <a:ext cx="11521440" cy="9502218"/>
+            <a:off x="320040" y="822960"/>
+            <a:ext cx="11521440" cy="4490627"/>
           </a:xfrm>
           <a:prstGeom prst="rect">
             <a:avLst/>

</xml_diff>